<commit_message>
Version 1.1 - Updated QA presentation
</commit_message>
<xml_diff>
--- a/QA-Presentation.pptx
+++ b/QA-Presentation.pptx
@@ -3190,7 +3190,7 @@
             </a:pPr>
             <a:r>
               <a:rPr lang="en-IN" sz="2400" dirty="0"/>
-              <a:t>Version: 1.0</a:t>
+              <a:t>Version: 1.1</a:t>
             </a:r>
           </a:p>
           <a:p>
@@ -3706,6 +3706,22 @@
               <a:rPr dirty="0"/>
               <a:t>Version 1.1 — Modified by Vigneshwaran — Added Forgot Password requirement</a:t>
             </a:r>
+            <a:r>
+              <a:rPr lang="en-US" dirty="0"/>
+              <a:t>.</a:t>
+            </a:r>
+          </a:p>
+          <a:p>
+            <a:pPr>
+              <a:buFont typeface="Arial" panose="020B0604020202020204" pitchFamily="34" charset="0"/>
+              <a:buChar char="•"/>
+              <a:defRPr sz="2400"/>
+            </a:pPr>
+            <a:r>
+              <a:rPr lang="en-US" dirty="0"/>
+              <a:t>Change description should be recorded for each version.</a:t>
+            </a:r>
+            <a:endParaRPr dirty="0"/>
           </a:p>
         </p:txBody>
       </p:sp>

</xml_diff>